<commit_message>
Clarifier le livrable Juridique RH et proposer une SAS pour SOLAR WRAP
</commit_message>
<xml_diff>
--- a/7 JURIDIQUE RH/SLIDE-JURY.pptx
+++ b/7 JURIDIQUE RH/SLIDE-JURY.pptx
@@ -502,25 +502,13 @@
           <a:lstStyle/>
           <a:p>
             <a:r>
-              <a:t>ORAL (45–60 secondes)</a:t>
+              <a:t>Sources et vérifications : SOURCES-ET-VERIFICATIONS.md.</a:t>
             </a:r>
           </a:p>
           <a:p/>
           <a:p>
             <a:r>
-              <a:t>SOLAR WRAP équipe les camions frigorifiques de ses clients avec un kit solaire. Pour démarrer simplement en Côte d’Ivoire, je propose une SARL et un installateur local qualifié. Avant le pilote, nous faisons confirmer les formalités de modification du camion, la sécurité électrique et les assurances. Un contrat précise la pose, les essais, la garantie et la maintenance. Le client reste responsable de son transport ; nous restons responsables de notre équipement et de son installation, selon les règles applicables. Enfin, les économies et l’autonomie seront mesurées avant d’être promises.</a:t>
-            </a:r>
-          </a:p>
-          <a:p/>
-          <a:p>
-            <a:r>
-              <a:t>Sources et vérifications : SOURCES-ET-VERIFICATIONS.md ; CEO 04-strategie/LA VISION DU CEO.MD ; Ventes §2 et5. DGTTC transformations/RTI et DGE : application au montage à confirmer.</a:t>
-            </a:r>
-          </a:p>
-          <a:p/>
-          <a:p>
-            <a:r>
-              <a:t>La SARL et le partenaire local sont des propositions. Le client reste exploitant, sans exclusion de nos responsabilités légales.</a:t>
+              <a:t>La SAS est une proposition ; décision et coût à valider par les fondateurs. Formalités du montage, compétences, assurances et contrats restent à confirmer avant le pilote. Aucune autorisation ni performance n’est annoncée comme obtenue.</a:t>
             </a:r>
           </a:p>
         </p:txBody>
@@ -3586,7 +3574,7 @@
         <p:spPr>
           <a:xfrm>
             <a:off x="548640" y="365760"/>
-            <a:ext cx="10972800" cy="274320"/>
+            <a:ext cx="10972800" cy="320040"/>
           </a:xfrm>
           <a:prstGeom prst="rect">
             <a:avLst/>
@@ -3601,7 +3589,7 @@
           <a:p>
             <a:pPr>
               <a:spcAft>
-                <a:spcPts val="1000"/>
+                <a:spcPts val="700"/>
               </a:spcAft>
               <a:defRPr sz="1300" b="1">
                 <a:solidFill>
@@ -3611,7 +3599,7 @@
               </a:defRPr>
             </a:pPr>
             <a:r>
-              <a:t>SOLAR WRAP   /   CÔTE D’IVOIRE                                      MAXIME · JURIDIQUE / RH</a:t>
+              <a:t>SOLAR WRAP  /  CÔTE D’IVOIRE                                  MAXIME · JURIDIQUE ET RH</a:t>
             </a:r>
           </a:p>
         </p:txBody>
@@ -3624,8 +3612,8 @@
         </p:nvSpPr>
         <p:spPr>
           <a:xfrm>
-            <a:off x="548640" y="914400"/>
-            <a:ext cx="10972800" cy="640080"/>
+            <a:off x="548640" y="932688"/>
+            <a:ext cx="10972800" cy="594360"/>
           </a:xfrm>
           <a:prstGeom prst="rect">
             <a:avLst/>
@@ -3640,9 +3628,9 @@
           <a:p>
             <a:pPr>
               <a:spcAft>
-                <a:spcPts val="1000"/>
+                <a:spcPts val="700"/>
               </a:spcAft>
-              <a:defRPr sz="3400" b="1">
+              <a:defRPr sz="3300" b="1">
                 <a:solidFill>
                   <a:srgbClr val="075D65"/>
                 </a:solidFill>
@@ -3650,7 +3638,7 @@
               </a:defRPr>
             </a:pPr>
             <a:r>
-              <a:t>Un kit sûr, un pilote encadré.</a:t>
+              <a:t>Un démarrage simple et organisé</a:t>
             </a:r>
           </a:p>
         </p:txBody>
@@ -3664,7 +3652,7 @@
         <p:spPr>
           <a:xfrm>
             <a:off x="548640" y="1691640"/>
-            <a:ext cx="10972800" cy="457200"/>
+            <a:ext cx="10972800" cy="548640"/>
           </a:xfrm>
           <a:prstGeom prst="rect">
             <a:avLst/>
@@ -3679,9 +3667,9 @@
           <a:p>
             <a:pPr>
               <a:spcAft>
-                <a:spcPts val="1000"/>
+                <a:spcPts val="700"/>
               </a:spcAft>
-              <a:defRPr sz="2300" b="0">
+              <a:defRPr sz="2100" b="0">
                 <a:solidFill>
                   <a:srgbClr val="17343F"/>
                 </a:solidFill>
@@ -3689,7 +3677,7 @@
               </a:defRPr>
             </a:pPr>
             <a:r>
-              <a:t>Nous équipons les camions frigorifiques des clients.</a:t>
+              <a:t>Un kit solaire pour aider à alimenter le froid des camions clients.</a:t>
             </a:r>
           </a:p>
         </p:txBody>
@@ -3702,7 +3690,7 @@
         </p:nvSpPr>
         <p:spPr>
           <a:xfrm>
-            <a:off x="548640" y="2514600"/>
+            <a:off x="548640" y="2468880"/>
             <a:ext cx="3566160" cy="2423160"/>
           </a:xfrm>
           <a:prstGeom prst="roundRect">
@@ -3745,7 +3733,7 @@
         </p:nvSpPr>
         <p:spPr>
           <a:xfrm>
-            <a:off x="749808" y="2697480"/>
+            <a:off x="731520" y="2642616"/>
             <a:ext cx="640080" cy="365760"/>
           </a:xfrm>
           <a:prstGeom prst="rect">
@@ -3761,9 +3749,9 @@
           <a:p>
             <a:pPr>
               <a:spcAft>
-                <a:spcPts val="1000"/>
+                <a:spcPts val="700"/>
               </a:spcAft>
-              <a:defRPr sz="2400" b="1">
+              <a:defRPr sz="2300" b="1">
                 <a:solidFill>
                   <a:srgbClr val="D9793B"/>
                 </a:solidFill>
@@ -3784,8 +3772,8 @@
         </p:nvSpPr>
         <p:spPr>
           <a:xfrm>
-            <a:off x="749808" y="3200400"/>
-            <a:ext cx="3154680" cy="640080"/>
+            <a:off x="731520" y="3163824"/>
+            <a:ext cx="3182112" cy="548640"/>
           </a:xfrm>
           <a:prstGeom prst="rect">
             <a:avLst/>
@@ -3800,7 +3788,7 @@
           <a:p>
             <a:pPr>
               <a:spcAft>
-                <a:spcPts val="1000"/>
+                <a:spcPts val="700"/>
               </a:spcAft>
               <a:defRPr sz="1700" b="1">
                 <a:solidFill>
@@ -3810,7 +3798,7 @@
               </a:defRPr>
             </a:pPr>
             <a:r>
-              <a:t>SÉCURISER LA POSE</a:t>
+              <a:t>UNE INSTALLATION SÛRE</a:t>
             </a:r>
           </a:p>
         </p:txBody>
@@ -3823,8 +3811,8 @@
         </p:nvSpPr>
         <p:spPr>
           <a:xfrm>
-            <a:off x="749808" y="3886200"/>
-            <a:ext cx="3154680" cy="914400"/>
+            <a:off x="731520" y="3822191"/>
+            <a:ext cx="3182112" cy="960120"/>
           </a:xfrm>
           <a:prstGeom prst="rect">
             <a:avLst/>
@@ -3839,9 +3827,9 @@
           <a:p>
             <a:pPr>
               <a:spcAft>
-                <a:spcPts val="1000"/>
+                <a:spcPts val="700"/>
               </a:spcAft>
-              <a:defRPr sz="1700" b="0">
+              <a:defRPr sz="1600" b="0">
                 <a:solidFill>
                   <a:srgbClr val="17343F"/>
                 </a:solidFill>
@@ -3849,15 +3837,15 @@
               </a:defRPr>
             </a:pPr>
             <a:r>
-              <a:t>Vérifier conformité véhicule</a:t>
+              <a:t>Vérifier les règles du camion</a:t>
             </a:r>
           </a:p>
           <a:p>
             <a:pPr>
               <a:spcAft>
-                <a:spcPts val="1000"/>
+                <a:spcPts val="700"/>
               </a:spcAft>
-              <a:defRPr sz="1700" b="0">
+              <a:defRPr sz="1600" b="0">
                 <a:solidFill>
                   <a:srgbClr val="17343F"/>
                 </a:solidFill>
@@ -3865,15 +3853,15 @@
               </a:defRPr>
             </a:pPr>
             <a:r>
-              <a:t>et sécurité électrique.</a:t>
+              <a:t>et de l’installation électrique.</a:t>
             </a:r>
           </a:p>
           <a:p>
             <a:pPr>
               <a:spcAft>
-                <a:spcPts val="1000"/>
+                <a:spcPts val="700"/>
               </a:spcAft>
-              <a:defRPr sz="1700" b="0">
+              <a:defRPr sz="1600" b="0">
                 <a:solidFill>
                   <a:srgbClr val="17343F"/>
                 </a:solidFill>
@@ -3881,7 +3869,7 @@
               </a:defRPr>
             </a:pPr>
             <a:r>
-              <a:t>Installateur local vérifié.</a:t>
+              <a:t>Confirmer les assurances.</a:t>
             </a:r>
           </a:p>
         </p:txBody>
@@ -3894,7 +3882,7 @@
         </p:nvSpPr>
         <p:spPr>
           <a:xfrm>
-            <a:off x="4315968" y="2514600"/>
+            <a:off x="4315968" y="2468880"/>
             <a:ext cx="3566160" cy="2423160"/>
           </a:xfrm>
           <a:prstGeom prst="roundRect">
@@ -3937,7 +3925,7 @@
         </p:nvSpPr>
         <p:spPr>
           <a:xfrm>
-            <a:off x="4517136" y="2697480"/>
+            <a:off x="4498848" y="2642616"/>
             <a:ext cx="640080" cy="365760"/>
           </a:xfrm>
           <a:prstGeom prst="rect">
@@ -3953,9 +3941,9 @@
           <a:p>
             <a:pPr>
               <a:spcAft>
-                <a:spcPts val="1000"/>
+                <a:spcPts val="700"/>
               </a:spcAft>
-              <a:defRPr sz="2400" b="1">
+              <a:defRPr sz="2300" b="1">
                 <a:solidFill>
                   <a:srgbClr val="D9793B"/>
                 </a:solidFill>
@@ -3976,8 +3964,8 @@
         </p:nvSpPr>
         <p:spPr>
           <a:xfrm>
-            <a:off x="4517136" y="3200400"/>
-            <a:ext cx="3154680" cy="640080"/>
+            <a:off x="4498848" y="3163824"/>
+            <a:ext cx="3182112" cy="548640"/>
           </a:xfrm>
           <a:prstGeom prst="rect">
             <a:avLst/>
@@ -3992,7 +3980,7 @@
           <a:p>
             <a:pPr>
               <a:spcAft>
-                <a:spcPts val="1000"/>
+                <a:spcPts val="700"/>
               </a:spcAft>
               <a:defRPr sz="1700" b="1">
                 <a:solidFill>
@@ -4002,7 +3990,7 @@
               </a:defRPr>
             </a:pPr>
             <a:r>
-              <a:t>ENCADRER LE PILOTE</a:t>
+              <a:t>DES ENGAGEMENTS ÉCRITS</a:t>
             </a:r>
           </a:p>
         </p:txBody>
@@ -4015,8 +4003,8 @@
         </p:nvSpPr>
         <p:spPr>
           <a:xfrm>
-            <a:off x="4517136" y="3886200"/>
-            <a:ext cx="3154680" cy="914400"/>
+            <a:off x="4498848" y="3822191"/>
+            <a:ext cx="3182112" cy="960120"/>
           </a:xfrm>
           <a:prstGeom prst="rect">
             <a:avLst/>
@@ -4031,9 +4019,9 @@
           <a:p>
             <a:pPr>
               <a:spcAft>
-                <a:spcPts val="1000"/>
+                <a:spcPts val="700"/>
               </a:spcAft>
-              <a:defRPr sz="1700" b="0">
+              <a:defRPr sz="1600" b="0">
                 <a:solidFill>
                   <a:srgbClr val="17343F"/>
                 </a:solidFill>
@@ -4041,15 +4029,15 @@
               </a:defRPr>
             </a:pPr>
             <a:r>
-              <a:t>Contrat : pose, essais,</a:t>
+              <a:t>Client, fournisseur,</a:t>
             </a:r>
           </a:p>
           <a:p>
             <a:pPr>
               <a:spcAft>
-                <a:spcPts val="1000"/>
+                <a:spcPts val="700"/>
               </a:spcAft>
-              <a:defRPr sz="1700" b="0">
+              <a:defRPr sz="1600" b="0">
                 <a:solidFill>
                   <a:srgbClr val="17343F"/>
                 </a:solidFill>
@@ -4057,15 +4045,15 @@
               </a:defRPr>
             </a:pPr>
             <a:r>
-              <a:t>garantie et maintenance.</a:t>
+              <a:t>installateur et assureur :</a:t>
             </a:r>
           </a:p>
           <a:p>
             <a:pPr>
               <a:spcAft>
-                <a:spcPts val="1000"/>
+                <a:spcPts val="700"/>
               </a:spcAft>
-              <a:defRPr sz="1700" b="0">
+              <a:defRPr sz="1600" b="0">
                 <a:solidFill>
                   <a:srgbClr val="17343F"/>
                 </a:solidFill>
@@ -4073,7 +4061,7 @@
               </a:defRPr>
             </a:pPr>
             <a:r>
-              <a:t>Assurances à confirmer.</a:t>
+              <a:t>qui fait quoi et qui garantit quoi.</a:t>
             </a:r>
           </a:p>
         </p:txBody>
@@ -4086,7 +4074,7 @@
         </p:nvSpPr>
         <p:spPr>
           <a:xfrm>
-            <a:off x="8083296" y="2514600"/>
+            <a:off x="8083296" y="2468880"/>
             <a:ext cx="3566160" cy="2423160"/>
           </a:xfrm>
           <a:prstGeom prst="roundRect">
@@ -4129,7 +4117,7 @@
         </p:nvSpPr>
         <p:spPr>
           <a:xfrm>
-            <a:off x="8284464" y="2697480"/>
+            <a:off x="8266175" y="2642616"/>
             <a:ext cx="640080" cy="365760"/>
           </a:xfrm>
           <a:prstGeom prst="rect">
@@ -4145,9 +4133,9 @@
           <a:p>
             <a:pPr>
               <a:spcAft>
-                <a:spcPts val="1000"/>
+                <a:spcPts val="700"/>
               </a:spcAft>
-              <a:defRPr sz="2400" b="1">
+              <a:defRPr sz="2300" b="1">
                 <a:solidFill>
                   <a:srgbClr val="D9793B"/>
                 </a:solidFill>
@@ -4168,8 +4156,8 @@
         </p:nvSpPr>
         <p:spPr>
           <a:xfrm>
-            <a:off x="8284464" y="3200400"/>
-            <a:ext cx="3154680" cy="640080"/>
+            <a:off x="8266175" y="3163824"/>
+            <a:ext cx="3182112" cy="548640"/>
           </a:xfrm>
           <a:prstGeom prst="rect">
             <a:avLst/>
@@ -4184,7 +4172,7 @@
           <a:p>
             <a:pPr>
               <a:spcAft>
-                <a:spcPts val="1000"/>
+                <a:spcPts val="700"/>
               </a:spcAft>
               <a:defRPr sz="1700" b="1">
                 <a:solidFill>
@@ -4194,7 +4182,7 @@
               </a:defRPr>
             </a:pPr>
             <a:r>
-              <a:t>GARDER UNE ÉQUIPE LÉGÈRE</a:t>
+              <a:t>LES BONNES COMPÉTENCES</a:t>
             </a:r>
           </a:p>
         </p:txBody>
@@ -4207,8 +4195,8 @@
         </p:nvSpPr>
         <p:spPr>
           <a:xfrm>
-            <a:off x="8284464" y="3886200"/>
-            <a:ext cx="3154680" cy="914400"/>
+            <a:off x="8266175" y="3822191"/>
+            <a:ext cx="3182112" cy="960120"/>
           </a:xfrm>
           <a:prstGeom prst="rect">
             <a:avLst/>
@@ -4223,9 +4211,9 @@
           <a:p>
             <a:pPr>
               <a:spcAft>
-                <a:spcPts val="1000"/>
+                <a:spcPts val="700"/>
               </a:spcAft>
-              <a:defRPr sz="1700" b="0">
+              <a:defRPr sz="1600" b="0">
                 <a:solidFill>
                   <a:srgbClr val="17343F"/>
                 </a:solidFill>
@@ -4233,15 +4221,15 @@
               </a:defRPr>
             </a:pPr>
             <a:r>
-              <a:t>Responsable projet/commercial.</a:t>
+              <a:t>Les fondateurs organisent.</a:t>
             </a:r>
           </a:p>
           <a:p>
             <a:pPr>
               <a:spcAft>
-                <a:spcPts val="1000"/>
+                <a:spcPts val="700"/>
               </a:spcAft>
-              <a:defRPr sz="1700" b="0">
+              <a:defRPr sz="1600" b="0">
                 <a:solidFill>
                   <a:srgbClr val="17343F"/>
                 </a:solidFill>
@@ -4249,15 +4237,15 @@
               </a:defRPr>
             </a:pPr>
             <a:r>
-              <a:t>Partenaire local pour</a:t>
+              <a:t>Une personne supervise la technique.</a:t>
             </a:r>
           </a:p>
           <a:p>
             <a:pPr>
               <a:spcAft>
-                <a:spcPts val="1000"/>
+                <a:spcPts val="700"/>
               </a:spcAft>
-              <a:defRPr sz="1700" b="0">
+              <a:defRPr sz="1600" b="0">
                 <a:solidFill>
                   <a:srgbClr val="17343F"/>
                 </a:solidFill>
@@ -4265,7 +4253,7 @@
               </a:defRPr>
             </a:pPr>
             <a:r>
-              <a:t>l’installation et la maintenance.</a:t>
+              <a:t>Un partenaire pose et entretient.</a:t>
             </a:r>
           </a:p>
         </p:txBody>
@@ -4278,7 +4266,7 @@
         </p:nvSpPr>
         <p:spPr>
           <a:xfrm>
-            <a:off x="594360" y="5257800"/>
+            <a:off x="594360" y="5166360"/>
             <a:ext cx="10972800" cy="594360"/>
           </a:xfrm>
           <a:prstGeom prst="rect">
@@ -4294,9 +4282,9 @@
           <a:p>
             <a:pPr>
               <a:spcAft>
-                <a:spcPts val="1000"/>
+                <a:spcPts val="700"/>
               </a:spcAft>
-              <a:defRPr sz="1900" b="1">
+              <a:defRPr sz="2200" b="1">
                 <a:solidFill>
                   <a:srgbClr val="17343F"/>
                 </a:solidFill>
@@ -4304,7 +4292,7 @@
               </a:defRPr>
             </a:pPr>
             <a:r>
-              <a:t>SARL proposée  •  Client : exploitation  •  SOLAR WRAP : kit et pose</a:t>
+              <a:t>SAS proposée pour préparer l’arrivée d’investisseurs.</a:t>
             </a:r>
           </a:p>
         </p:txBody>
@@ -4317,7 +4305,7 @@
         </p:nvSpPr>
         <p:spPr>
           <a:xfrm>
-            <a:off x="594360" y="5989320"/>
+            <a:off x="594360" y="5870448"/>
             <a:ext cx="10972800" cy="457200"/>
           </a:xfrm>
           <a:prstGeom prst="rect">
@@ -4333,9 +4321,9 @@
           <a:p>
             <a:pPr>
               <a:spcAft>
-                <a:spcPts val="1000"/>
+                <a:spcPts val="700"/>
               </a:spcAft>
-              <a:defRPr sz="2200" b="1">
+              <a:defRPr sz="2300" b="1">
                 <a:solidFill>
                   <a:srgbClr val="075D65"/>
                 </a:solidFill>
@@ -4343,7 +4331,7 @@
               </a:defRPr>
             </a:pPr>
             <a:r>
-              <a:t>Mesurer les économies et l’autonomie avant de les promettre.</a:t>
+              <a:t>Tester chez un client avant de promettre des économies.</a:t>
             </a:r>
           </a:p>
         </p:txBody>
@@ -4356,8 +4344,8 @@
         </p:nvSpPr>
         <p:spPr>
           <a:xfrm>
-            <a:off x="594360" y="6510528"/>
-            <a:ext cx="10972800" cy="182880"/>
+            <a:off x="594360" y="6473952"/>
+            <a:ext cx="10972800" cy="228600"/>
           </a:xfrm>
           <a:prstGeom prst="rect">
             <a:avLst/>
@@ -4372,7 +4360,7 @@
           <a:p>
             <a:pPr>
               <a:spcAft>
-                <a:spcPts val="1000"/>
+                <a:spcPts val="700"/>
               </a:spcAft>
               <a:defRPr sz="1000" b="0">
                 <a:solidFill>
@@ -4382,7 +4370,7 @@
               </a:defRPr>
             </a:pPr>
             <a:r>
-              <a:t>Propositions à valider · Aucune homologation, couverture ou performance annoncée comme acquise.</a:t>
+              <a:t>Propositions du pôle Juridique / RH, à valider par le groupe · Version 4 · 27 octobre 2026</a:t>
             </a:r>
           </a:p>
         </p:txBody>

</xml_diff>